<commit_message>
Frontend- show categories in mobile menu
</commit_message>
<xml_diff>
--- a/.lessons/56 Category, Subcategory and Child Category Setup/22 Frontend- show categories in mobile menu/1.pptx
+++ b/.lessons/56 Category, Subcategory and Child Category Setup/22 Frontend- show categories in mobile menu/1.pptx
@@ -6,8 +6,11 @@
   </p:sldMasterIdLst>
   <p:sldIdLst>
     <p:sldId id="413" r:id="rId2"/>
-    <p:sldId id="414" r:id="rId3"/>
-    <p:sldId id="400" r:id="rId4"/>
+    <p:sldId id="415" r:id="rId3"/>
+    <p:sldId id="416" r:id="rId4"/>
+    <p:sldId id="417" r:id="rId5"/>
+    <p:sldId id="414" r:id="rId6"/>
+    <p:sldId id="400" r:id="rId7"/>
   </p:sldIdLst>
   <p:sldSz cx="12192000" cy="6858000"/>
   <p:notesSz cx="6858000" cy="9144000"/>
@@ -261,7 +264,7 @@
           <a:p>
             <a:fld id="{3E102D2E-813C-461C-9963-687A650C48C0}" type="datetimeFigureOut">
               <a:rPr lang="en-US" smtClean="0"/>
-              <a:t>6/26/2025</a:t>
+              <a:t>9/5/2025</a:t>
             </a:fld>
             <a:endParaRPr lang="en-US"/>
           </a:p>
@@ -459,7 +462,7 @@
           <a:p>
             <a:fld id="{3E102D2E-813C-461C-9963-687A650C48C0}" type="datetimeFigureOut">
               <a:rPr lang="en-US" smtClean="0"/>
-              <a:t>6/26/2025</a:t>
+              <a:t>9/5/2025</a:t>
             </a:fld>
             <a:endParaRPr lang="en-US"/>
           </a:p>
@@ -667,7 +670,7 @@
           <a:p>
             <a:fld id="{3E102D2E-813C-461C-9963-687A650C48C0}" type="datetimeFigureOut">
               <a:rPr lang="en-US" smtClean="0"/>
-              <a:t>6/26/2025</a:t>
+              <a:t>9/5/2025</a:t>
             </a:fld>
             <a:endParaRPr lang="en-US"/>
           </a:p>
@@ -865,7 +868,7 @@
           <a:p>
             <a:fld id="{3E102D2E-813C-461C-9963-687A650C48C0}" type="datetimeFigureOut">
               <a:rPr lang="en-US" smtClean="0"/>
-              <a:t>6/26/2025</a:t>
+              <a:t>9/5/2025</a:t>
             </a:fld>
             <a:endParaRPr lang="en-US"/>
           </a:p>
@@ -1140,7 +1143,7 @@
           <a:p>
             <a:fld id="{3E102D2E-813C-461C-9963-687A650C48C0}" type="datetimeFigureOut">
               <a:rPr lang="en-US" smtClean="0"/>
-              <a:t>6/26/2025</a:t>
+              <a:t>9/5/2025</a:t>
             </a:fld>
             <a:endParaRPr lang="en-US"/>
           </a:p>
@@ -1405,7 +1408,7 @@
           <a:p>
             <a:fld id="{3E102D2E-813C-461C-9963-687A650C48C0}" type="datetimeFigureOut">
               <a:rPr lang="en-US" smtClean="0"/>
-              <a:t>6/26/2025</a:t>
+              <a:t>9/5/2025</a:t>
             </a:fld>
             <a:endParaRPr lang="en-US"/>
           </a:p>
@@ -1817,7 +1820,7 @@
           <a:p>
             <a:fld id="{3E102D2E-813C-461C-9963-687A650C48C0}" type="datetimeFigureOut">
               <a:rPr lang="en-US" smtClean="0"/>
-              <a:t>6/26/2025</a:t>
+              <a:t>9/5/2025</a:t>
             </a:fld>
             <a:endParaRPr lang="en-US"/>
           </a:p>
@@ -1958,7 +1961,7 @@
           <a:p>
             <a:fld id="{3E102D2E-813C-461C-9963-687A650C48C0}" type="datetimeFigureOut">
               <a:rPr lang="en-US" smtClean="0"/>
-              <a:t>6/26/2025</a:t>
+              <a:t>9/5/2025</a:t>
             </a:fld>
             <a:endParaRPr lang="en-US"/>
           </a:p>
@@ -2071,7 +2074,7 @@
           <a:p>
             <a:fld id="{3E102D2E-813C-461C-9963-687A650C48C0}" type="datetimeFigureOut">
               <a:rPr lang="en-US" smtClean="0"/>
-              <a:t>6/26/2025</a:t>
+              <a:t>9/5/2025</a:t>
             </a:fld>
             <a:endParaRPr lang="en-US"/>
           </a:p>
@@ -2382,7 +2385,7 @@
           <a:p>
             <a:fld id="{3E102D2E-813C-461C-9963-687A650C48C0}" type="datetimeFigureOut">
               <a:rPr lang="en-US" smtClean="0"/>
-              <a:t>6/26/2025</a:t>
+              <a:t>9/5/2025</a:t>
             </a:fld>
             <a:endParaRPr lang="en-US"/>
           </a:p>
@@ -2670,7 +2673,7 @@
           <a:p>
             <a:fld id="{3E102D2E-813C-461C-9963-687A650C48C0}" type="datetimeFigureOut">
               <a:rPr lang="en-US" smtClean="0"/>
-              <a:t>6/26/2025</a:t>
+              <a:t>9/5/2025</a:t>
             </a:fld>
             <a:endParaRPr lang="en-US"/>
           </a:p>
@@ -2911,7 +2914,7 @@
           <a:p>
             <a:fld id="{3E102D2E-813C-461C-9963-687A650C48C0}" type="datetimeFigureOut">
               <a:rPr lang="en-US" smtClean="0"/>
-              <a:t>6/26/2025</a:t>
+              <a:t>9/5/2025</a:t>
             </a:fld>
             <a:endParaRPr lang="en-US"/>
           </a:p>
@@ -3369,21 +3372,72 @@
               <a:buNone/>
             </a:pPr>
             <a:r>
-              <a:rPr kumimoji="0" lang="en-US" altLang="en-US" sz="1300" b="0" i="0" u="none" strike="noStrike" cap="none" normalizeH="0" baseline="0">
-                <a:ln>
-                  <a:noFill/>
-                </a:ln>
-                <a:solidFill>
-                  <a:schemeClr val="tx1"/>
-                </a:solidFill>
-                <a:effectLst/>
+              <a:rPr lang="az-Latn-AZ" altLang="en-US" sz="1300" b="1">
                 <a:latin typeface="Arial" panose="020B0604020202020204" pitchFamily="34" charset="0"/>
               </a:rPr>
-              <a:t>.</a:t>
-            </a:r>
-          </a:p>
-        </p:txBody>
-      </p:sp>
+              <a:t>Telefon</a:t>
+            </a:r>
+            <a:r>
+              <a:rPr lang="az-Latn-AZ" altLang="en-US" sz="1300">
+                <a:latin typeface="Arial" panose="020B0604020202020204" pitchFamily="34" charset="0"/>
+              </a:rPr>
+              <a:t> üçün </a:t>
+            </a:r>
+            <a:r>
+              <a:rPr lang="az-Latn-AZ" altLang="en-US" sz="1300" b="1">
+                <a:latin typeface="Arial" panose="020B0604020202020204" pitchFamily="34" charset="0"/>
+              </a:rPr>
+              <a:t>Category</a:t>
+            </a:r>
+            <a:r>
+              <a:rPr lang="az-Latn-AZ" altLang="en-US" sz="1300">
+                <a:latin typeface="Arial" panose="020B0604020202020204" pitchFamily="34" charset="0"/>
+              </a:rPr>
+              <a:t> -lərin konfiqurasiya edilməsi.</a:t>
+            </a:r>
+            <a:endParaRPr kumimoji="0" lang="en-US" altLang="en-US" sz="1300" b="0" i="0" u="none" strike="noStrike" cap="none" normalizeH="0" baseline="0">
+              <a:ln>
+                <a:noFill/>
+              </a:ln>
+              <a:solidFill>
+                <a:schemeClr val="tx1"/>
+              </a:solidFill>
+              <a:effectLst/>
+              <a:latin typeface="Arial" panose="020B0604020202020204" pitchFamily="34" charset="0"/>
+            </a:endParaRPr>
+          </a:p>
+        </p:txBody>
+      </p:sp>
+      <p:pic>
+        <p:nvPicPr>
+          <p:cNvPr id="4" name="Picture 3">
+            <a:extLst>
+              <a:ext uri="{FF2B5EF4-FFF2-40B4-BE49-F238E27FC236}">
+                <a16:creationId xmlns:a16="http://schemas.microsoft.com/office/drawing/2014/main" id="{2F594ADF-099E-83C6-73A3-3DB331B38DFE}"/>
+              </a:ext>
+            </a:extLst>
+          </p:cNvPr>
+          <p:cNvPicPr>
+            <a:picLocks noChangeAspect="1"/>
+          </p:cNvPicPr>
+          <p:nvPr/>
+        </p:nvPicPr>
+        <p:blipFill>
+          <a:blip r:embed="rId2"/>
+          <a:stretch>
+            <a:fillRect/>
+          </a:stretch>
+        </p:blipFill>
+        <p:spPr>
+          <a:xfrm>
+            <a:off x="9848523" y="2009098"/>
+            <a:ext cx="2343477" cy="4848902"/>
+          </a:xfrm>
+          <a:prstGeom prst="rect">
+            <a:avLst/>
+          </a:prstGeom>
+        </p:spPr>
+      </p:pic>
     </p:spTree>
     <p:extLst>
       <p:ext uri="{BB962C8B-B14F-4D97-AF65-F5344CB8AC3E}">
@@ -3398,6 +3452,327 @@
 </file>
 
 <file path=ppt/slides/slide2.xml><?xml version="1.0" encoding="utf-8"?>
+<p:sld xmlns:a="http://schemas.openxmlformats.org/drawingml/2006/main" xmlns:r="http://schemas.openxmlformats.org/officeDocument/2006/relationships" xmlns:p="http://schemas.openxmlformats.org/presentationml/2006/main">
+  <p:cSld>
+    <p:spTree>
+      <p:nvGrpSpPr>
+        <p:cNvPr id="1" name="">
+          <a:extLst>
+            <a:ext uri="{FF2B5EF4-FFF2-40B4-BE49-F238E27FC236}">
+              <a16:creationId xmlns:a16="http://schemas.microsoft.com/office/drawing/2014/main" id="{47F8E033-0DF3-A79A-FB85-3837BDF4C382}"/>
+            </a:ext>
+          </a:extLst>
+        </p:cNvPr>
+        <p:cNvGrpSpPr/>
+        <p:nvPr/>
+      </p:nvGrpSpPr>
+      <p:grpSpPr>
+        <a:xfrm>
+          <a:off x="0" y="0"/>
+          <a:ext cx="0" cy="0"/>
+          <a:chOff x="0" y="0"/>
+          <a:chExt cx="0" cy="0"/>
+        </a:xfrm>
+      </p:grpSpPr>
+      <p:sp>
+        <p:nvSpPr>
+          <p:cNvPr id="3" name="TextBox 2">
+            <a:extLst>
+              <a:ext uri="{FF2B5EF4-FFF2-40B4-BE49-F238E27FC236}">
+                <a16:creationId xmlns:a16="http://schemas.microsoft.com/office/drawing/2014/main" id="{6E2510EE-D5F9-6816-2930-CDC5D540D05A}"/>
+              </a:ext>
+            </a:extLst>
+          </p:cNvPr>
+          <p:cNvSpPr txBox="1"/>
+          <p:nvPr/>
+        </p:nvSpPr>
+        <p:spPr>
+          <a:xfrm>
+            <a:off x="217714" y="255046"/>
+            <a:ext cx="11756571" cy="355354"/>
+          </a:xfrm>
+          <a:prstGeom prst="rect">
+            <a:avLst/>
+          </a:prstGeom>
+          <a:noFill/>
+        </p:spPr>
+        <p:txBody>
+          <a:bodyPr wrap="square">
+            <a:spAutoFit/>
+          </a:bodyPr>
+          <a:lstStyle/>
+          <a:p>
+            <a:pPr>
+              <a:lnSpc>
+                <a:spcPct val="150000"/>
+              </a:lnSpc>
+              <a:buNone/>
+            </a:pPr>
+            <a:r>
+              <a:rPr kumimoji="0" lang="en-US" altLang="en-US" sz="1300" b="0" i="0" u="none" strike="noStrike" cap="none" normalizeH="0" baseline="0">
+                <a:ln>
+                  <a:noFill/>
+                </a:ln>
+                <a:solidFill>
+                  <a:schemeClr val="tx1"/>
+                </a:solidFill>
+                <a:effectLst/>
+                <a:latin typeface="Arial" panose="020B0604020202020204" pitchFamily="34" charset="0"/>
+              </a:rPr>
+              <a:t>.</a:t>
+            </a:r>
+          </a:p>
+        </p:txBody>
+      </p:sp>
+      <p:pic>
+        <p:nvPicPr>
+          <p:cNvPr id="4" name="Picture 3">
+            <a:extLst>
+              <a:ext uri="{FF2B5EF4-FFF2-40B4-BE49-F238E27FC236}">
+                <a16:creationId xmlns:a16="http://schemas.microsoft.com/office/drawing/2014/main" id="{9F958526-E46C-DCBC-E23A-F3D94C680801}"/>
+              </a:ext>
+            </a:extLst>
+          </p:cNvPr>
+          <p:cNvPicPr>
+            <a:picLocks noChangeAspect="1"/>
+          </p:cNvPicPr>
+          <p:nvPr/>
+        </p:nvPicPr>
+        <p:blipFill>
+          <a:blip r:embed="rId2"/>
+          <a:stretch>
+            <a:fillRect/>
+          </a:stretch>
+        </p:blipFill>
+        <p:spPr>
+          <a:xfrm>
+            <a:off x="4396509" y="933666"/>
+            <a:ext cx="7795491" cy="5924334"/>
+          </a:xfrm>
+          <a:prstGeom prst="rect">
+            <a:avLst/>
+          </a:prstGeom>
+        </p:spPr>
+      </p:pic>
+    </p:spTree>
+    <p:extLst>
+      <p:ext uri="{BB962C8B-B14F-4D97-AF65-F5344CB8AC3E}">
+        <p14:creationId xmlns:p14="http://schemas.microsoft.com/office/powerpoint/2010/main" val="224009130"/>
+      </p:ext>
+    </p:extLst>
+  </p:cSld>
+  <p:clrMapOvr>
+    <a:masterClrMapping/>
+  </p:clrMapOvr>
+</p:sld>
+</file>
+
+<file path=ppt/slides/slide3.xml><?xml version="1.0" encoding="utf-8"?>
+<p:sld xmlns:a="http://schemas.openxmlformats.org/drawingml/2006/main" xmlns:r="http://schemas.openxmlformats.org/officeDocument/2006/relationships" xmlns:p="http://schemas.openxmlformats.org/presentationml/2006/main">
+  <p:cSld>
+    <p:spTree>
+      <p:nvGrpSpPr>
+        <p:cNvPr id="1" name="">
+          <a:extLst>
+            <a:ext uri="{FF2B5EF4-FFF2-40B4-BE49-F238E27FC236}">
+              <a16:creationId xmlns:a16="http://schemas.microsoft.com/office/drawing/2014/main" id="{D8E2465A-DC5D-29CC-853A-D279BB788AAF}"/>
+            </a:ext>
+          </a:extLst>
+        </p:cNvPr>
+        <p:cNvGrpSpPr/>
+        <p:nvPr/>
+      </p:nvGrpSpPr>
+      <p:grpSpPr>
+        <a:xfrm>
+          <a:off x="0" y="0"/>
+          <a:ext cx="0" cy="0"/>
+          <a:chOff x="0" y="0"/>
+          <a:chExt cx="0" cy="0"/>
+        </a:xfrm>
+      </p:grpSpPr>
+      <p:sp>
+        <p:nvSpPr>
+          <p:cNvPr id="3" name="TextBox 2">
+            <a:extLst>
+              <a:ext uri="{FF2B5EF4-FFF2-40B4-BE49-F238E27FC236}">
+                <a16:creationId xmlns:a16="http://schemas.microsoft.com/office/drawing/2014/main" id="{E6B4CA4B-BEDC-5BD5-41FF-E0E12E1D4F2A}"/>
+              </a:ext>
+            </a:extLst>
+          </p:cNvPr>
+          <p:cNvSpPr txBox="1"/>
+          <p:nvPr/>
+        </p:nvSpPr>
+        <p:spPr>
+          <a:xfrm>
+            <a:off x="217714" y="153446"/>
+            <a:ext cx="11756571" cy="355354"/>
+          </a:xfrm>
+          <a:prstGeom prst="rect">
+            <a:avLst/>
+          </a:prstGeom>
+          <a:noFill/>
+        </p:spPr>
+        <p:txBody>
+          <a:bodyPr wrap="square">
+            <a:spAutoFit/>
+          </a:bodyPr>
+          <a:lstStyle/>
+          <a:p>
+            <a:pPr>
+              <a:lnSpc>
+                <a:spcPct val="150000"/>
+              </a:lnSpc>
+              <a:buNone/>
+            </a:pPr>
+            <a:r>
+              <a:rPr lang="en-US" altLang="en-US" sz="1300">
+                <a:latin typeface="Arial" panose="020B0604020202020204" pitchFamily="34" charset="0"/>
+              </a:rPr>
+              <a:t>resources\views\frontend\layouts\menu.blade.php</a:t>
+            </a:r>
+            <a:endParaRPr kumimoji="0" lang="en-US" altLang="en-US" sz="1300" b="0" i="0" u="none" strike="noStrike" cap="none" normalizeH="0" baseline="0">
+              <a:ln>
+                <a:noFill/>
+              </a:ln>
+              <a:solidFill>
+                <a:schemeClr val="tx1"/>
+              </a:solidFill>
+              <a:effectLst/>
+              <a:latin typeface="Arial" panose="020B0604020202020204" pitchFamily="34" charset="0"/>
+            </a:endParaRPr>
+          </a:p>
+        </p:txBody>
+      </p:sp>
+      <p:pic>
+        <p:nvPicPr>
+          <p:cNvPr id="4" name="Picture 3">
+            <a:extLst>
+              <a:ext uri="{FF2B5EF4-FFF2-40B4-BE49-F238E27FC236}">
+                <a16:creationId xmlns:a16="http://schemas.microsoft.com/office/drawing/2014/main" id="{A4B42770-959F-C228-C4A4-F7059B467BF6}"/>
+              </a:ext>
+            </a:extLst>
+          </p:cNvPr>
+          <p:cNvPicPr>
+            <a:picLocks noChangeAspect="1"/>
+          </p:cNvPicPr>
+          <p:nvPr/>
+        </p:nvPicPr>
+        <p:blipFill>
+          <a:blip r:embed="rId2"/>
+          <a:stretch>
+            <a:fillRect/>
+          </a:stretch>
+        </p:blipFill>
+        <p:spPr>
+          <a:xfrm>
+            <a:off x="4054763" y="743242"/>
+            <a:ext cx="8222241" cy="6114757"/>
+          </a:xfrm>
+          <a:prstGeom prst="rect">
+            <a:avLst/>
+          </a:prstGeom>
+        </p:spPr>
+      </p:pic>
+    </p:spTree>
+    <p:extLst>
+      <p:ext uri="{BB962C8B-B14F-4D97-AF65-F5344CB8AC3E}">
+        <p14:creationId xmlns:p14="http://schemas.microsoft.com/office/powerpoint/2010/main" val="254558145"/>
+      </p:ext>
+    </p:extLst>
+  </p:cSld>
+  <p:clrMapOvr>
+    <a:masterClrMapping/>
+  </p:clrMapOvr>
+</p:sld>
+</file>
+
+<file path=ppt/slides/slide4.xml><?xml version="1.0" encoding="utf-8"?>
+<p:sld xmlns:a="http://schemas.openxmlformats.org/drawingml/2006/main" xmlns:r="http://schemas.openxmlformats.org/officeDocument/2006/relationships" xmlns:p="http://schemas.openxmlformats.org/presentationml/2006/main">
+  <p:cSld>
+    <p:spTree>
+      <p:nvGrpSpPr>
+        <p:cNvPr id="1" name="">
+          <a:extLst>
+            <a:ext uri="{FF2B5EF4-FFF2-40B4-BE49-F238E27FC236}">
+              <a16:creationId xmlns:a16="http://schemas.microsoft.com/office/drawing/2014/main" id="{5F5EDD16-45CB-C70F-7DD5-1273AA43E9E9}"/>
+            </a:ext>
+          </a:extLst>
+        </p:cNvPr>
+        <p:cNvGrpSpPr/>
+        <p:nvPr/>
+      </p:nvGrpSpPr>
+      <p:grpSpPr>
+        <a:xfrm>
+          <a:off x="0" y="0"/>
+          <a:ext cx="0" cy="0"/>
+          <a:chOff x="0" y="0"/>
+          <a:chExt cx="0" cy="0"/>
+        </a:xfrm>
+      </p:grpSpPr>
+      <p:sp>
+        <p:nvSpPr>
+          <p:cNvPr id="3" name="TextBox 2">
+            <a:extLst>
+              <a:ext uri="{FF2B5EF4-FFF2-40B4-BE49-F238E27FC236}">
+                <a16:creationId xmlns:a16="http://schemas.microsoft.com/office/drawing/2014/main" id="{B617168C-7F36-3DBF-E6E3-DA997C83AD4A}"/>
+              </a:ext>
+            </a:extLst>
+          </p:cNvPr>
+          <p:cNvSpPr txBox="1"/>
+          <p:nvPr/>
+        </p:nvSpPr>
+        <p:spPr>
+          <a:xfrm>
+            <a:off x="217714" y="255046"/>
+            <a:ext cx="11756571" cy="355354"/>
+          </a:xfrm>
+          <a:prstGeom prst="rect">
+            <a:avLst/>
+          </a:prstGeom>
+          <a:noFill/>
+        </p:spPr>
+        <p:txBody>
+          <a:bodyPr wrap="square">
+            <a:spAutoFit/>
+          </a:bodyPr>
+          <a:lstStyle/>
+          <a:p>
+            <a:pPr>
+              <a:lnSpc>
+                <a:spcPct val="150000"/>
+              </a:lnSpc>
+              <a:buNone/>
+            </a:pPr>
+            <a:r>
+              <a:rPr kumimoji="0" lang="en-US" altLang="en-US" sz="1300" b="0" i="0" u="none" strike="noStrike" cap="none" normalizeH="0" baseline="0">
+                <a:ln>
+                  <a:noFill/>
+                </a:ln>
+                <a:solidFill>
+                  <a:schemeClr val="tx1"/>
+                </a:solidFill>
+                <a:effectLst/>
+                <a:latin typeface="Arial" panose="020B0604020202020204" pitchFamily="34" charset="0"/>
+              </a:rPr>
+              <a:t>.</a:t>
+            </a:r>
+          </a:p>
+        </p:txBody>
+      </p:sp>
+    </p:spTree>
+    <p:extLst>
+      <p:ext uri="{BB962C8B-B14F-4D97-AF65-F5344CB8AC3E}">
+        <p14:creationId xmlns:p14="http://schemas.microsoft.com/office/powerpoint/2010/main" val="548314579"/>
+      </p:ext>
+    </p:extLst>
+  </p:cSld>
+  <p:clrMapOvr>
+    <a:masterClrMapping/>
+  </p:clrMapOvr>
+</p:sld>
+</file>
+
+<file path=ppt/slides/slide5.xml><?xml version="1.0" encoding="utf-8"?>
 <p:sld xmlns:a="http://schemas.openxmlformats.org/drawingml/2006/main" xmlns:r="http://schemas.openxmlformats.org/officeDocument/2006/relationships" xmlns:p="http://schemas.openxmlformats.org/presentationml/2006/main">
   <p:cSld>
     <p:spTree>
@@ -3483,7 +3858,7 @@
 </p:sld>
 </file>
 
-<file path=ppt/slides/slide3.xml><?xml version="1.0" encoding="utf-8"?>
+<file path=ppt/slides/slide6.xml><?xml version="1.0" encoding="utf-8"?>
 <p:sld xmlns:a="http://schemas.openxmlformats.org/drawingml/2006/main" xmlns:r="http://schemas.openxmlformats.org/officeDocument/2006/relationships" xmlns:p="http://schemas.openxmlformats.org/presentationml/2006/main">
   <p:cSld>
     <p:spTree>

</xml_diff>